<commit_message>
feat: 하네스 기반 PPT 생성 파이프라인 + Template Contract 도입
6-역할 파이프라인 (Planner / Generator / Validator / Evaluator /
Refiner / Assembler) 을 구축하고, Generator·Evaluator·Refiner 는
Agent subagent 로 격리 실행해 자기 과대평가 편향을 mechanism-level
에서 차단한다. `template_contract.py` 는 마스터 XML 해시 비교와
CONTENT_SAFE 안전 영역을 런타임에서 강제하는 TemplateGuard 컨텍스트
매니저를 제공한다.

주요 변경:
- harness/ — 6-역할 모듈 + prompts/ + loop.py 오케스트레이션
- template_contract.py + ref/locked_registry.yaml — 레지스트리/보호
- ppt_utils.py — Assembler 페이지 번호 동기화, 하네스 연동 헬퍼 추가
- .claude/commands/generate-ppt.md — v2 워크플로로 개편 (v1 보관)
- CLAUDE.md — Type A 입력 계약 및 각종 디자인 규칙 보강
- ref/표지.pptx — 마스터 경미 조정 (페이지 번호 정규화 기반 해시)

Co-Authored-By: Claude Opus 4.7 (1M context) <noreply@anthropic.com>
</commit_message>
<xml_diff>
--- a/ref/표지.pptx
+++ b/ref/표지.pptx
@@ -233,7 +233,7 @@
             <a:fld id="{920865B8-6288-4184-A9BF-A3164421EED3}" type="datetimeFigureOut">
               <a:rPr lang="ko-KR" altLang="en-US" smtClean="0"/>
               <a:pPr/>
-              <a:t>2026-01-27</a:t>
+              <a:t>2026-04-21</a:t>
             </a:fld>
             <a:endParaRPr lang="ko-KR" altLang="en-US"/>
           </a:p>
@@ -1370,6 +1370,23 @@
               <a:defRPr/>
             </a:pPr>
             <a:r>
+              <a:rPr kumimoji="0" lang="en-US" altLang="ko-KR" sz="1200" b="0" i="0" u="none" strike="noStrike" kern="1200" cap="none" spc="0" normalizeH="0" baseline="0" noProof="0" dirty="0">
+                <a:ln>
+                  <a:noFill/>
+                </a:ln>
+                <a:solidFill>
+                  <a:schemeClr val="tx1"/>
+                </a:solidFill>
+                <a:effectLst/>
+                <a:uLnTx/>
+                <a:uFillTx/>
+                <a:latin typeface="맑은 고딕" pitchFamily="50" charset="-127"/>
+                <a:ea typeface="맑은 고딕" pitchFamily="50" charset="-127"/>
+                <a:cs typeface="+mn-cs"/>
+              </a:rPr>
+              <a:t>SDP</a:t>
+            </a:r>
+            <a:r>
               <a:rPr kumimoji="0" lang="ko-KR" altLang="en-US" sz="1200" b="0" i="0" u="none" strike="noStrike" kern="1200" cap="none" spc="0" normalizeH="0" baseline="0" noProof="0" dirty="0">
                 <a:ln>
                   <a:noFill/>
@@ -1384,7 +1401,7 @@
                 <a:ea typeface="맑은 고딕" pitchFamily="50" charset="-127"/>
                 <a:cs typeface="+mn-cs"/>
               </a:rPr>
-              <a:t>연구개발본부</a:t>
+              <a:t>센터</a:t>
             </a:r>
           </a:p>
         </p:txBody>
@@ -1827,12 +1844,8 @@
           <a:lstStyle/>
           <a:p>
             <a:r>
-              <a:rPr lang="en-US" altLang="ko-KR" sz="4800" b="1" dirty="0"/>
-              <a:t>LLM</a:t>
-            </a:r>
-            <a:r>
               <a:rPr lang="ko-KR" altLang="en-US" sz="4800" b="1" dirty="0"/>
-              <a:t> 내재화</a:t>
+              <a:t>주제</a:t>
             </a:r>
           </a:p>
         </p:txBody>
@@ -1854,7 +1867,7 @@
           <a:p>
             <a:r>
               <a:rPr lang="en-US" altLang="ko-KR" dirty="0"/>
-              <a:t>2025. 10. 29</a:t>
+              <a:t>2026. 04. 21</a:t>
             </a:r>
             <a:endParaRPr lang="ko-KR" altLang="en-US" dirty="0"/>
           </a:p>
@@ -1884,11 +1897,11 @@
           <a:p>
             <a:pPr algn="ctr"/>
             <a:r>
-              <a:rPr lang="ko-KR" altLang="en-US" sz="2400" b="1">
+              <a:rPr lang="ko-KR" altLang="en-US" sz="2400" b="1" dirty="0">
                 <a:latin typeface="맑은 고딕" pitchFamily="50" charset="-127"/>
                 <a:ea typeface="맑은 고딕" pitchFamily="50" charset="-127"/>
               </a:rPr>
-              <a:t>미래융합설계센터 알고리즘개발팀 강민규 선임</a:t>
+              <a:t>미래융합설계센터 알고리즘개발팀 강민규 책임</a:t>
             </a:r>
             <a:endParaRPr lang="ko-KR" altLang="en-US" sz="2400" b="1" dirty="0">
               <a:solidFill>
@@ -2023,43 +2036,17 @@
         <p:spPr>
           <a:xfrm>
             <a:off x="252001" y="622038"/>
-            <a:ext cx="9396000" cy="1386011"/>
+            <a:ext cx="9396000" cy="474865"/>
           </a:xfrm>
         </p:spPr>
         <p:txBody>
           <a:bodyPr/>
           <a:lstStyle/>
           <a:p>
-            <a:r>
-              <a:rPr lang="en-US" altLang="ko-KR" dirty="0"/>
-              <a:t>SAD/SDD</a:t>
-            </a:r>
-            <a:r>
-              <a:rPr lang="ko-KR" altLang="en-US" dirty="0"/>
-              <a:t> 자동화 생성 솔루션</a:t>
-            </a:r>
-            <a:endParaRPr lang="en-US" altLang="ko-KR" dirty="0"/>
-          </a:p>
-          <a:p>
-            <a:r>
-              <a:rPr lang="en-US" altLang="ko-KR" dirty="0"/>
-              <a:t>AI </a:t>
-            </a:r>
-            <a:r>
-              <a:rPr lang="ko-KR" altLang="en-US" dirty="0"/>
-              <a:t>코딩 어시스턴트 시스템 구축</a:t>
-            </a:r>
-            <a:endParaRPr lang="en-US" altLang="ko-KR" dirty="0"/>
-          </a:p>
-          <a:p>
-            <a:r>
-              <a:rPr lang="en-US" altLang="ko-KR" dirty="0"/>
-              <a:t>LLM</a:t>
-            </a:r>
-            <a:r>
-              <a:rPr lang="ko-KR" altLang="en-US" dirty="0"/>
-              <a:t> 로드맵</a:t>
-            </a:r>
+            <a:pPr marL="0" indent="0">
+              <a:buNone/>
+            </a:pPr>
+            <a:endParaRPr lang="ko-KR" altLang="en-US" dirty="0"/>
           </a:p>
         </p:txBody>
       </p:sp>

</xml_diff>